<commit_message>
docs(jun11): reframe cluster ask as nice-to-have; add Hassan+Hammad role split
Cluster question corrected after Zuraiz challenged it. The earlier
"hundreds of laptop-hours" bottleneck claim only holds under stacked
worst-case assumptions (fine sliding windows + full per-window null +
both methods + full corpus). The committed Sprint-4 scope (Tier-3 grid,
4 levels x 3 seeds x 5 pieces, full-piece Granger) is ~12-15 laptop-
hours: one overnight run. Slide 8, script, and Q-T6 now say explicitly
"not a blocker; cluster would buy denser jitter grids and finer windows
for H1 robustness". No fake requirements in front of coordinators.

Script appendix: retitled for Hassan AND Hammad (Zuraiz absent from
the meeting). New role-split section: Hassan presents + owns WP3
questions; Hammad covers WP2 + continuity from Status Meeting III;
agreed escape hatch for deep audio/integration/dashboard questions.
</commit_message>
<xml_diff>
--- a/output/jun11_status_meeting_iv.pptx
+++ b/output/jun11_status_meeting_iv.pptx
@@ -7831,7 +7831,7 @@
                 </a:solidFill>
                 <a:latin typeface="Segoe UI Semibold"/>
               </a:rPr>
-              <a:t>2 · Coordinators: compute for the next iteration</a:t>
+              <a:t>2 · Coordinators: cluster access (nice-to-have, not a blocker)</a:t>
             </a:r>
           </a:p>
           <a:p>
@@ -7847,7 +7847,7 @@
                 </a:solidFill>
                 <a:latin typeface="Segoe UI"/>
               </a:rPr>
-              <a:t>Is there a path to CPU time on a Bamberg or HSLU cluster? Per-window Granger across the corpus is the compute bottleneck for the latency-injection runs: hundreds of hours on our laptops, roughly one day on a 32-64 core node.</a:t>
+              <a:t>Is CPU time available on a Bamberg or HSLU cluster? The planned next-iteration scope runs overnight on our laptops. Cluster access would let us run denser jitter grids and finer analysis windows, which strengthens the H1 robustness checks.</a:t>
             </a:r>
           </a:p>
         </p:txBody>

</xml_diff>

<commit_message>
docs(jun11): swap in audit-corrected PPTX render
</commit_message>
<xml_diff>
--- a/output/jun11_status_meeting_iv.pptx
+++ b/output/jun11_status_meeting_iv.pptx
@@ -5057,7 +5057,7 @@
                 </a:solidFill>
                 <a:latin typeface="Segoe UI"/>
               </a:rPr>
-              <a:t>pieces significantly above the null (p &lt; 0.001)</a:t>
+              <a:t>pieces significantly above the null (p &lt; 0.005)</a:t>
             </a:r>
           </a:p>
         </p:txBody>
@@ -5735,7 +5735,7 @@
                 </a:solidFill>
                 <a:latin typeface="Segoe UI"/>
               </a:rPr>
-              <a:t>Methods agree on quartets, diverge on full choir (42 vs 25 of 56 edges). That gap is itself a finding: a third of standard edges rely on linear magnitude, not pattern structure.</a:t>
+              <a:t>Methods agree on quartets, diverge on full choir (42 vs 25 of 56 edges). That gap is itself a finding: about 40% of standard edges (17 of 42) rely on linear magnitude, not pattern structure.</a:t>
             </a:r>
           </a:p>
         </p:txBody>
@@ -5789,7 +5789,7 @@
                 </a:solidFill>
                 <a:latin typeface="Segoe UI Semibold"/>
               </a:rPr>
-              <a:t>The Sprint-2 reference result reproduces exactly; the pipeline now scales to the corpus.</a:t>
+              <a:t>Sprint-2 reference reproduces (11/12 edges, density 0.917); the pipeline now scales to the corpus.</a:t>
             </a:r>
           </a:p>
         </p:txBody>
@@ -6262,7 +6262,7 @@
                 </a:solidFill>
                 <a:latin typeface="Segoe UI"/>
               </a:rPr>
-              <a:t>WP2: 5 of 10 stratified videos have usable pose tracks (best 98.5% detection); the rest are UI screen captures. The five passing videos form the working set.</a:t>
+              <a:t>WP2: 5 of 10 stratified videos have usable pose tracks (best 98.5% detection); the rest are UI captures or low-res tile grids. The five passing videos form the working set.</a:t>
             </a:r>
           </a:p>
           <a:p>
@@ -6818,7 +6818,7 @@
                           </a:solidFill>
                           <a:latin typeface="Segoe UI"/>
                         </a:rPr>
-                        <a:t>Download ChoralSynth (open license, Zenodo) · follow up ESMUC</a:t>
+                        <a:t>Download ChoralSynth (Zenodo, research licence) · follow up ESMUC</a:t>
                       </a:r>
                     </a:p>
                   </a:txBody>
@@ -7287,7 +7287,7 @@
                 </a:solidFill>
                 <a:latin typeface="Segoe UI"/>
               </a:rPr>
-              <a:t>ESMUC and ChoralSynth not yet in Tier‑2. ChoralSynth is openly licensed on Zenodo and scheduled for next iteration; ESMUC requires a license (open question).</a:t>
+              <a:t>ESMUC and ChoralSynth not yet in Tier‑2. ChoralSynth is freely available on Zenodo for research and scheduled for next iteration; ESMUC requires a license (open question).</a:t>
             </a:r>
           </a:p>
           <a:p>
@@ -7459,7 +7459,7 @@
                 </a:solidFill>
                 <a:latin typeface="Segoe UI"/>
               </a:rPr>
-              <a:t>p &lt; 0.001 means 0 of 200 permutations exceeded the observed value.</a:t>
+              <a:t>p &lt; 0.005 means 0 of 200 permutations exceeded the observed value.</a:t>
             </a:r>
           </a:p>
         </p:txBody>
@@ -7771,7 +7771,7 @@
                 </a:solidFill>
                 <a:latin typeface="Segoe UI"/>
               </a:rPr>
-              <a:t>Do you have institutional access to the ESMUC multitrack dataset? ChoralSynth is openly licensed on Zenodo and we will download it ourselves; ESMUC is the only dataset where we need support.</a:t>
+              <a:t>Do you have institutional access to the ESMUC multitrack dataset? ChoralSynth is freely available on Zenodo for research and we will download it ourselves; ESMUC is the only dataset where we need support.</a:t>
             </a:r>
           </a:p>
         </p:txBody>

</xml_diff>

<commit_message>
docs(jun11): update status meeting presentation with revised content
</commit_message>
<xml_diff>
--- a/output/jun11_status_meeting_iv.pptx
+++ b/output/jun11_status_meeting_iv.pptx
@@ -5,16 +5,16 @@
     <p:sldMasterId id="2147483648" r:id="rId1"/>
   </p:sldMasterIdLst>
   <p:sldIdLst>
-    <p:sldId id="256" r:id="rId7"/>
-    <p:sldId id="257" r:id="rId8"/>
-    <p:sldId id="258" r:id="rId9"/>
-    <p:sldId id="259" r:id="rId10"/>
-    <p:sldId id="260" r:id="rId11"/>
-    <p:sldId id="261" r:id="rId12"/>
-    <p:sldId id="262" r:id="rId13"/>
-    <p:sldId id="263" r:id="rId14"/>
+    <p:sldId id="256" r:id="rId2"/>
+    <p:sldId id="257" r:id="rId3"/>
+    <p:sldId id="258" r:id="rId4"/>
+    <p:sldId id="259" r:id="rId5"/>
+    <p:sldId id="260" r:id="rId6"/>
+    <p:sldId id="261" r:id="rId7"/>
+    <p:sldId id="262" r:id="rId8"/>
+    <p:sldId id="263" r:id="rId9"/>
   </p:sldIdLst>
-  <p:sldSz cx="12191695" cy="6858000" type="screen4x3"/>
+  <p:sldSz cx="12192000" cy="6858000"/>
   <p:notesSz cx="6858000" cy="9144000"/>
   <p:defaultTextStyle>
     <a:defPPr>
@@ -111,6 +111,22 @@
       </a:defRPr>
     </a:lvl9pPr>
   </p:defaultTextStyle>
+  <p:extLst>
+    <p:ext uri="{EFAFB233-063F-42B5-8137-9DF3F51BA10A}">
+      <p15:sldGuideLst xmlns:p15="http://schemas.microsoft.com/office/powerpoint/2012/main">
+        <p15:guide id="1" orient="horz" pos="2160">
+          <p15:clr>
+            <a:srgbClr val="A4A3A4"/>
+          </p15:clr>
+        </p15:guide>
+        <p15:guide id="2" pos="2880">
+          <p15:clr>
+            <a:srgbClr val="A4A3A4"/>
+          </p15:clr>
+        </p15:guide>
+      </p15:sldGuideLst>
+    </p:ext>
+  </p:extLst>
 </p:presentation>
 </file>
 
@@ -152,10 +168,9 @@
           <a:lstStyle/>
           <a:p>
             <a:r>
-              <a:rPr lang="en-US" smtClean="0"/>
+              <a:rPr lang="en-US"/>
               <a:t>Click to edit Master title style</a:t>
             </a:r>
-            <a:endParaRPr lang="en-US"/>
           </a:p>
         </p:txBody>
       </p:sp>
@@ -271,10 +286,9 @@
           </a:lstStyle>
           <a:p>
             <a:r>
-              <a:rPr lang="en-US" smtClean="0"/>
+              <a:rPr lang="en-US"/>
               <a:t>Click to edit Master subtitle style</a:t>
             </a:r>
-            <a:endParaRPr lang="en-US"/>
           </a:p>
         </p:txBody>
       </p:sp>
@@ -295,7 +309,7 @@
           <a:p>
             <a:fld id="{5BCAD085-E8A6-8845-BD4E-CB4CCA059FC4}" type="datetimeFigureOut">
               <a:rPr lang="en-US" smtClean="0"/>
-              <a:t>1/27/13</a:t>
+              <a:t>6/11/2026</a:t>
             </a:fld>
             <a:endParaRPr lang="en-US"/>
           </a:p>
@@ -389,10 +403,9 @@
           <a:lstStyle/>
           <a:p>
             <a:r>
-              <a:rPr lang="en-US" smtClean="0"/>
+              <a:rPr lang="en-US"/>
               <a:t>Click to edit Master title style</a:t>
             </a:r>
-            <a:endParaRPr lang="en-US"/>
           </a:p>
         </p:txBody>
       </p:sp>
@@ -413,38 +426,37 @@
           <a:p>
             <a:pPr lvl="0"/>
             <a:r>
-              <a:rPr lang="en-US" smtClean="0"/>
+              <a:rPr lang="en-US"/>
               <a:t>Click to edit Master text styles</a:t>
             </a:r>
           </a:p>
           <a:p>
             <a:pPr lvl="1"/>
             <a:r>
-              <a:rPr lang="en-US" smtClean="0"/>
+              <a:rPr lang="en-US"/>
               <a:t>Second level</a:t>
             </a:r>
           </a:p>
           <a:p>
             <a:pPr lvl="2"/>
             <a:r>
-              <a:rPr lang="en-US" smtClean="0"/>
+              <a:rPr lang="en-US"/>
               <a:t>Third level</a:t>
             </a:r>
           </a:p>
           <a:p>
             <a:pPr lvl="3"/>
             <a:r>
-              <a:rPr lang="en-US" smtClean="0"/>
+              <a:rPr lang="en-US"/>
               <a:t>Fourth level</a:t>
             </a:r>
           </a:p>
           <a:p>
             <a:pPr lvl="4"/>
             <a:r>
-              <a:rPr lang="en-US" smtClean="0"/>
+              <a:rPr lang="en-US"/>
               <a:t>Fifth level</a:t>
             </a:r>
-            <a:endParaRPr lang="en-US"/>
           </a:p>
         </p:txBody>
       </p:sp>
@@ -465,7 +477,7 @@
           <a:p>
             <a:fld id="{5BCAD085-E8A6-8845-BD4E-CB4CCA059FC4}" type="datetimeFigureOut">
               <a:rPr lang="en-US" smtClean="0"/>
-              <a:t>1/27/13</a:t>
+              <a:t>6/11/2026</a:t>
             </a:fld>
             <a:endParaRPr lang="en-US"/>
           </a:p>
@@ -564,10 +576,9 @@
           <a:lstStyle/>
           <a:p>
             <a:r>
-              <a:rPr lang="en-US" smtClean="0"/>
+              <a:rPr lang="en-US"/>
               <a:t>Click to edit Master title style</a:t>
             </a:r>
-            <a:endParaRPr lang="en-US"/>
           </a:p>
         </p:txBody>
       </p:sp>
@@ -593,38 +604,37 @@
           <a:p>
             <a:pPr lvl="0"/>
             <a:r>
-              <a:rPr lang="en-US" smtClean="0"/>
+              <a:rPr lang="en-US"/>
               <a:t>Click to edit Master text styles</a:t>
             </a:r>
           </a:p>
           <a:p>
             <a:pPr lvl="1"/>
             <a:r>
-              <a:rPr lang="en-US" smtClean="0"/>
+              <a:rPr lang="en-US"/>
               <a:t>Second level</a:t>
             </a:r>
           </a:p>
           <a:p>
             <a:pPr lvl="2"/>
             <a:r>
-              <a:rPr lang="en-US" smtClean="0"/>
+              <a:rPr lang="en-US"/>
               <a:t>Third level</a:t>
             </a:r>
           </a:p>
           <a:p>
             <a:pPr lvl="3"/>
             <a:r>
-              <a:rPr lang="en-US" smtClean="0"/>
+              <a:rPr lang="en-US"/>
               <a:t>Fourth level</a:t>
             </a:r>
           </a:p>
           <a:p>
             <a:pPr lvl="4"/>
             <a:r>
-              <a:rPr lang="en-US" smtClean="0"/>
+              <a:rPr lang="en-US"/>
               <a:t>Fifth level</a:t>
             </a:r>
-            <a:endParaRPr lang="en-US"/>
           </a:p>
         </p:txBody>
       </p:sp>
@@ -645,7 +655,7 @@
           <a:p>
             <a:fld id="{5BCAD085-E8A6-8845-BD4E-CB4CCA059FC4}" type="datetimeFigureOut">
               <a:rPr lang="en-US" smtClean="0"/>
-              <a:t>1/27/13</a:t>
+              <a:t>6/11/2026</a:t>
             </a:fld>
             <a:endParaRPr lang="en-US"/>
           </a:p>
@@ -739,10 +749,9 @@
           <a:lstStyle/>
           <a:p>
             <a:r>
-              <a:rPr lang="en-US" smtClean="0"/>
+              <a:rPr lang="en-US"/>
               <a:t>Click to edit Master title style</a:t>
             </a:r>
-            <a:endParaRPr lang="en-US"/>
           </a:p>
         </p:txBody>
       </p:sp>
@@ -763,38 +772,37 @@
           <a:p>
             <a:pPr lvl="0"/>
             <a:r>
-              <a:rPr lang="en-US" smtClean="0"/>
+              <a:rPr lang="en-US"/>
               <a:t>Click to edit Master text styles</a:t>
             </a:r>
           </a:p>
           <a:p>
             <a:pPr lvl="1"/>
             <a:r>
-              <a:rPr lang="en-US" smtClean="0"/>
+              <a:rPr lang="en-US"/>
               <a:t>Second level</a:t>
             </a:r>
           </a:p>
           <a:p>
             <a:pPr lvl="2"/>
             <a:r>
-              <a:rPr lang="en-US" smtClean="0"/>
+              <a:rPr lang="en-US"/>
               <a:t>Third level</a:t>
             </a:r>
           </a:p>
           <a:p>
             <a:pPr lvl="3"/>
             <a:r>
-              <a:rPr lang="en-US" smtClean="0"/>
+              <a:rPr lang="en-US"/>
               <a:t>Fourth level</a:t>
             </a:r>
           </a:p>
           <a:p>
             <a:pPr lvl="4"/>
             <a:r>
-              <a:rPr lang="en-US" smtClean="0"/>
+              <a:rPr lang="en-US"/>
               <a:t>Fifth level</a:t>
             </a:r>
-            <a:endParaRPr lang="en-US"/>
           </a:p>
         </p:txBody>
       </p:sp>
@@ -815,7 +823,7 @@
           <a:p>
             <a:fld id="{5BCAD085-E8A6-8845-BD4E-CB4CCA059FC4}" type="datetimeFigureOut">
               <a:rPr lang="en-US" smtClean="0"/>
-              <a:t>1/27/13</a:t>
+              <a:t>6/11/2026</a:t>
             </a:fld>
             <a:endParaRPr lang="en-US"/>
           </a:p>
@@ -918,10 +926,9 @@
           </a:lstStyle>
           <a:p>
             <a:r>
-              <a:rPr lang="en-US" smtClean="0"/>
+              <a:rPr lang="en-US"/>
               <a:t>Click to edit Master title style</a:t>
             </a:r>
-            <a:endParaRPr lang="en-US"/>
           </a:p>
         </p:txBody>
       </p:sp>
@@ -1038,7 +1045,7 @@
           <a:p>
             <a:pPr lvl="0"/>
             <a:r>
-              <a:rPr lang="en-US" smtClean="0"/>
+              <a:rPr lang="en-US"/>
               <a:t>Click to edit Master text styles</a:t>
             </a:r>
           </a:p>
@@ -1061,7 +1068,7 @@
           <a:p>
             <a:fld id="{5BCAD085-E8A6-8845-BD4E-CB4CCA059FC4}" type="datetimeFigureOut">
               <a:rPr lang="en-US" smtClean="0"/>
-              <a:t>1/27/13</a:t>
+              <a:t>6/11/2026</a:t>
             </a:fld>
             <a:endParaRPr lang="en-US"/>
           </a:p>
@@ -1155,10 +1162,9 @@
           <a:lstStyle/>
           <a:p>
             <a:r>
-              <a:rPr lang="en-US" smtClean="0"/>
+              <a:rPr lang="en-US"/>
               <a:t>Click to edit Master title style</a:t>
             </a:r>
-            <a:endParaRPr lang="en-US"/>
           </a:p>
         </p:txBody>
       </p:sp>
@@ -1212,38 +1218,37 @@
           <a:p>
             <a:pPr lvl="0"/>
             <a:r>
-              <a:rPr lang="en-US" smtClean="0"/>
+              <a:rPr lang="en-US"/>
               <a:t>Click to edit Master text styles</a:t>
             </a:r>
           </a:p>
           <a:p>
             <a:pPr lvl="1"/>
             <a:r>
-              <a:rPr lang="en-US" smtClean="0"/>
+              <a:rPr lang="en-US"/>
               <a:t>Second level</a:t>
             </a:r>
           </a:p>
           <a:p>
             <a:pPr lvl="2"/>
             <a:r>
-              <a:rPr lang="en-US" smtClean="0"/>
+              <a:rPr lang="en-US"/>
               <a:t>Third level</a:t>
             </a:r>
           </a:p>
           <a:p>
             <a:pPr lvl="3"/>
             <a:r>
-              <a:rPr lang="en-US" smtClean="0"/>
+              <a:rPr lang="en-US"/>
               <a:t>Fourth level</a:t>
             </a:r>
           </a:p>
           <a:p>
             <a:pPr lvl="4"/>
             <a:r>
-              <a:rPr lang="en-US" smtClean="0"/>
+              <a:rPr lang="en-US"/>
               <a:t>Fifth level</a:t>
             </a:r>
-            <a:endParaRPr lang="en-US"/>
           </a:p>
         </p:txBody>
       </p:sp>
@@ -1297,38 +1302,37 @@
           <a:p>
             <a:pPr lvl="0"/>
             <a:r>
-              <a:rPr lang="en-US" smtClean="0"/>
+              <a:rPr lang="en-US"/>
               <a:t>Click to edit Master text styles</a:t>
             </a:r>
           </a:p>
           <a:p>
             <a:pPr lvl="1"/>
             <a:r>
-              <a:rPr lang="en-US" smtClean="0"/>
+              <a:rPr lang="en-US"/>
               <a:t>Second level</a:t>
             </a:r>
           </a:p>
           <a:p>
             <a:pPr lvl="2"/>
             <a:r>
-              <a:rPr lang="en-US" smtClean="0"/>
+              <a:rPr lang="en-US"/>
               <a:t>Third level</a:t>
             </a:r>
           </a:p>
           <a:p>
             <a:pPr lvl="3"/>
             <a:r>
-              <a:rPr lang="en-US" smtClean="0"/>
+              <a:rPr lang="en-US"/>
               <a:t>Fourth level</a:t>
             </a:r>
           </a:p>
           <a:p>
             <a:pPr lvl="4"/>
             <a:r>
-              <a:rPr lang="en-US" smtClean="0"/>
+              <a:rPr lang="en-US"/>
               <a:t>Fifth level</a:t>
             </a:r>
-            <a:endParaRPr lang="en-US"/>
           </a:p>
         </p:txBody>
       </p:sp>
@@ -1349,7 +1353,7 @@
           <a:p>
             <a:fld id="{5BCAD085-E8A6-8845-BD4E-CB4CCA059FC4}" type="datetimeFigureOut">
               <a:rPr lang="en-US" smtClean="0"/>
-              <a:t>1/27/13</a:t>
+              <a:t>6/11/2026</a:t>
             </a:fld>
             <a:endParaRPr lang="en-US"/>
           </a:p>
@@ -1447,10 +1451,9 @@
           </a:lstStyle>
           <a:p>
             <a:r>
-              <a:rPr lang="en-US" smtClean="0"/>
+              <a:rPr lang="en-US"/>
               <a:t>Click to edit Master title style</a:t>
             </a:r>
-            <a:endParaRPr lang="en-US"/>
           </a:p>
         </p:txBody>
       </p:sp>
@@ -1513,7 +1516,7 @@
           <a:p>
             <a:pPr lvl="0"/>
             <a:r>
-              <a:rPr lang="en-US" smtClean="0"/>
+              <a:rPr lang="en-US"/>
               <a:t>Click to edit Master text styles</a:t>
             </a:r>
           </a:p>
@@ -1569,38 +1572,37 @@
           <a:p>
             <a:pPr lvl="0"/>
             <a:r>
-              <a:rPr lang="en-US" smtClean="0"/>
+              <a:rPr lang="en-US"/>
               <a:t>Click to edit Master text styles</a:t>
             </a:r>
           </a:p>
           <a:p>
             <a:pPr lvl="1"/>
             <a:r>
-              <a:rPr lang="en-US" smtClean="0"/>
+              <a:rPr lang="en-US"/>
               <a:t>Second level</a:t>
             </a:r>
           </a:p>
           <a:p>
             <a:pPr lvl="2"/>
             <a:r>
-              <a:rPr lang="en-US" smtClean="0"/>
+              <a:rPr lang="en-US"/>
               <a:t>Third level</a:t>
             </a:r>
           </a:p>
           <a:p>
             <a:pPr lvl="3"/>
             <a:r>
-              <a:rPr lang="en-US" smtClean="0"/>
+              <a:rPr lang="en-US"/>
               <a:t>Fourth level</a:t>
             </a:r>
           </a:p>
           <a:p>
             <a:pPr lvl="4"/>
             <a:r>
-              <a:rPr lang="en-US" smtClean="0"/>
+              <a:rPr lang="en-US"/>
               <a:t>Fifth level</a:t>
             </a:r>
-            <a:endParaRPr lang="en-US"/>
           </a:p>
         </p:txBody>
       </p:sp>
@@ -1663,7 +1665,7 @@
           <a:p>
             <a:pPr lvl="0"/>
             <a:r>
-              <a:rPr lang="en-US" smtClean="0"/>
+              <a:rPr lang="en-US"/>
               <a:t>Click to edit Master text styles</a:t>
             </a:r>
           </a:p>
@@ -1719,38 +1721,37 @@
           <a:p>
             <a:pPr lvl="0"/>
             <a:r>
-              <a:rPr lang="en-US" smtClean="0"/>
+              <a:rPr lang="en-US"/>
               <a:t>Click to edit Master text styles</a:t>
             </a:r>
           </a:p>
           <a:p>
             <a:pPr lvl="1"/>
             <a:r>
-              <a:rPr lang="en-US" smtClean="0"/>
+              <a:rPr lang="en-US"/>
               <a:t>Second level</a:t>
             </a:r>
           </a:p>
           <a:p>
             <a:pPr lvl="2"/>
             <a:r>
-              <a:rPr lang="en-US" smtClean="0"/>
+              <a:rPr lang="en-US"/>
               <a:t>Third level</a:t>
             </a:r>
           </a:p>
           <a:p>
             <a:pPr lvl="3"/>
             <a:r>
-              <a:rPr lang="en-US" smtClean="0"/>
+              <a:rPr lang="en-US"/>
               <a:t>Fourth level</a:t>
             </a:r>
           </a:p>
           <a:p>
             <a:pPr lvl="4"/>
             <a:r>
-              <a:rPr lang="en-US" smtClean="0"/>
+              <a:rPr lang="en-US"/>
               <a:t>Fifth level</a:t>
             </a:r>
-            <a:endParaRPr lang="en-US"/>
           </a:p>
         </p:txBody>
       </p:sp>
@@ -1771,7 +1772,7 @@
           <a:p>
             <a:fld id="{5BCAD085-E8A6-8845-BD4E-CB4CCA059FC4}" type="datetimeFigureOut">
               <a:rPr lang="en-US" smtClean="0"/>
-              <a:t>1/27/13</a:t>
+              <a:t>6/11/2026</a:t>
             </a:fld>
             <a:endParaRPr lang="en-US"/>
           </a:p>
@@ -1865,10 +1866,9 @@
           <a:lstStyle/>
           <a:p>
             <a:r>
-              <a:rPr lang="en-US" smtClean="0"/>
+              <a:rPr lang="en-US"/>
               <a:t>Click to edit Master title style</a:t>
             </a:r>
-            <a:endParaRPr lang="en-US"/>
           </a:p>
         </p:txBody>
       </p:sp>
@@ -1889,7 +1889,7 @@
           <a:p>
             <a:fld id="{5BCAD085-E8A6-8845-BD4E-CB4CCA059FC4}" type="datetimeFigureOut">
               <a:rPr lang="en-US" smtClean="0"/>
-              <a:t>1/27/13</a:t>
+              <a:t>6/11/2026</a:t>
             </a:fld>
             <a:endParaRPr lang="en-US"/>
           </a:p>
@@ -1984,7 +1984,7 @@
           <a:p>
             <a:fld id="{5BCAD085-E8A6-8845-BD4E-CB4CCA059FC4}" type="datetimeFigureOut">
               <a:rPr lang="en-US" smtClean="0"/>
-              <a:t>1/27/13</a:t>
+              <a:t>6/11/2026</a:t>
             </a:fld>
             <a:endParaRPr lang="en-US"/>
           </a:p>
@@ -2087,10 +2087,9 @@
           </a:lstStyle>
           <a:p>
             <a:r>
-              <a:rPr lang="en-US" smtClean="0"/>
+              <a:rPr lang="en-US"/>
               <a:t>Click to edit Master title style</a:t>
             </a:r>
-            <a:endParaRPr lang="en-US"/>
           </a:p>
         </p:txBody>
       </p:sp>
@@ -2144,38 +2143,37 @@
           <a:p>
             <a:pPr lvl="0"/>
             <a:r>
-              <a:rPr lang="en-US" smtClean="0"/>
+              <a:rPr lang="en-US"/>
               <a:t>Click to edit Master text styles</a:t>
             </a:r>
           </a:p>
           <a:p>
             <a:pPr lvl="1"/>
             <a:r>
-              <a:rPr lang="en-US" smtClean="0"/>
+              <a:rPr lang="en-US"/>
               <a:t>Second level</a:t>
             </a:r>
           </a:p>
           <a:p>
             <a:pPr lvl="2"/>
             <a:r>
-              <a:rPr lang="en-US" smtClean="0"/>
+              <a:rPr lang="en-US"/>
               <a:t>Third level</a:t>
             </a:r>
           </a:p>
           <a:p>
             <a:pPr lvl="3"/>
             <a:r>
-              <a:rPr lang="en-US" smtClean="0"/>
+              <a:rPr lang="en-US"/>
               <a:t>Fourth level</a:t>
             </a:r>
           </a:p>
           <a:p>
             <a:pPr lvl="4"/>
             <a:r>
-              <a:rPr lang="en-US" smtClean="0"/>
+              <a:rPr lang="en-US"/>
               <a:t>Fifth level</a:t>
             </a:r>
-            <a:endParaRPr lang="en-US"/>
           </a:p>
         </p:txBody>
       </p:sp>
@@ -2238,7 +2236,7 @@
           <a:p>
             <a:pPr lvl="0"/>
             <a:r>
-              <a:rPr lang="en-US" smtClean="0"/>
+              <a:rPr lang="en-US"/>
               <a:t>Click to edit Master text styles</a:t>
             </a:r>
           </a:p>
@@ -2261,7 +2259,7 @@
           <a:p>
             <a:fld id="{5BCAD085-E8A6-8845-BD4E-CB4CCA059FC4}" type="datetimeFigureOut">
               <a:rPr lang="en-US" smtClean="0"/>
-              <a:t>1/27/13</a:t>
+              <a:t>6/11/2026</a:t>
             </a:fld>
             <a:endParaRPr lang="en-US"/>
           </a:p>
@@ -2364,10 +2362,9 @@
           </a:lstStyle>
           <a:p>
             <a:r>
-              <a:rPr lang="en-US" smtClean="0"/>
+              <a:rPr lang="en-US"/>
               <a:t>Click to edit Master title style</a:t>
             </a:r>
-            <a:endParaRPr lang="en-US"/>
           </a:p>
         </p:txBody>
       </p:sp>
@@ -2491,7 +2488,7 @@
           <a:p>
             <a:pPr lvl="0"/>
             <a:r>
-              <a:rPr lang="en-US" smtClean="0"/>
+              <a:rPr lang="en-US"/>
               <a:t>Click to edit Master text styles</a:t>
             </a:r>
           </a:p>
@@ -2514,7 +2511,7 @@
           <a:p>
             <a:fld id="{5BCAD085-E8A6-8845-BD4E-CB4CCA059FC4}" type="datetimeFigureOut">
               <a:rPr lang="en-US" smtClean="0"/>
-              <a:t>1/27/13</a:t>
+              <a:t>6/11/2026</a:t>
             </a:fld>
             <a:endParaRPr lang="en-US"/>
           </a:p>
@@ -2623,10 +2620,9 @@
           <a:lstStyle/>
           <a:p>
             <a:r>
-              <a:rPr lang="en-US" smtClean="0"/>
+              <a:rPr lang="en-US"/>
               <a:t>Click to edit Master title style</a:t>
             </a:r>
-            <a:endParaRPr lang="en-US"/>
           </a:p>
         </p:txBody>
       </p:sp>
@@ -2657,38 +2653,37 @@
           <a:p>
             <a:pPr lvl="0"/>
             <a:r>
-              <a:rPr lang="en-US" smtClean="0"/>
+              <a:rPr lang="en-US"/>
               <a:t>Click to edit Master text styles</a:t>
             </a:r>
           </a:p>
           <a:p>
             <a:pPr lvl="1"/>
             <a:r>
-              <a:rPr lang="en-US" smtClean="0"/>
+              <a:rPr lang="en-US"/>
               <a:t>Second level</a:t>
             </a:r>
           </a:p>
           <a:p>
             <a:pPr lvl="2"/>
             <a:r>
-              <a:rPr lang="en-US" smtClean="0"/>
+              <a:rPr lang="en-US"/>
               <a:t>Third level</a:t>
             </a:r>
           </a:p>
           <a:p>
             <a:pPr lvl="3"/>
             <a:r>
-              <a:rPr lang="en-US" smtClean="0"/>
+              <a:rPr lang="en-US"/>
               <a:t>Fourth level</a:t>
             </a:r>
           </a:p>
           <a:p>
             <a:pPr lvl="4"/>
             <a:r>
-              <a:rPr lang="en-US" smtClean="0"/>
+              <a:rPr lang="en-US"/>
               <a:t>Fifth level</a:t>
             </a:r>
-            <a:endParaRPr lang="en-US"/>
           </a:p>
         </p:txBody>
       </p:sp>
@@ -2727,7 +2722,7 @@
           <a:p>
             <a:fld id="{5BCAD085-E8A6-8845-BD4E-CB4CCA059FC4}" type="datetimeFigureOut">
               <a:rPr lang="en-US" smtClean="0"/>
-              <a:t>1/27/13</a:t>
+              <a:t>6/11/2026</a:t>
             </a:fld>
             <a:endParaRPr lang="en-US"/>
           </a:p>
@@ -3086,7 +3081,7 @@
 </file>
 
 <file path=ppt/slides/slide1.xml><?xml version="1.0" encoding="utf-8"?>
-<p:sld xmlns:a="http://schemas.openxmlformats.org/drawingml/2006/main" xmlns:p="http://schemas.openxmlformats.org/presentationml/2006/main" xmlns:r="http://schemas.openxmlformats.org/officeDocument/2006/relationships">
+<p:sld xmlns:a="http://schemas.openxmlformats.org/drawingml/2006/main" xmlns:r="http://schemas.openxmlformats.org/officeDocument/2006/relationships" xmlns:p="http://schemas.openxmlformats.org/presentationml/2006/main">
   <p:cSld>
     <p:bg>
       <p:bgPr>
@@ -3102,7 +3097,14 @@
         <p:cNvGrpSpPr/>
         <p:nvPr/>
       </p:nvGrpSpPr>
-      <p:grpSpPr/>
+      <p:grpSpPr>
+        <a:xfrm>
+          <a:off x="0" y="0"/>
+          <a:ext cx="0" cy="0"/>
+          <a:chOff x="0" y="0"/>
+          <a:chExt cx="0" cy="0"/>
+        </a:xfrm>
+      </p:grpSpPr>
       <p:sp>
         <p:nvSpPr>
           <p:cNvPr id="2" name="TextBox 1"/>
@@ -3120,7 +3122,7 @@
           <a:noFill/>
         </p:spPr>
         <p:txBody>
-          <a:bodyPr wrap="square" anchor="t" lIns="27432" rIns="27432" tIns="18288" bIns="18288">
+          <a:bodyPr wrap="square" lIns="27432" tIns="18288" rIns="27432" bIns="18288" anchor="t">
             <a:spAutoFit/>
           </a:bodyPr>
           <a:lstStyle/>
@@ -3159,7 +3161,7 @@
           <a:noFill/>
         </p:spPr>
         <p:txBody>
-          <a:bodyPr wrap="square" anchor="t" lIns="27432" rIns="27432" tIns="18288" bIns="18288">
+          <a:bodyPr wrap="square" lIns="27432" tIns="18288" rIns="27432" bIns="18288" anchor="t">
             <a:spAutoFit/>
           </a:bodyPr>
           <a:lstStyle/>
@@ -3233,7 +3235,7 @@
           <a:noFill/>
         </p:spPr>
         <p:txBody>
-          <a:bodyPr wrap="square" anchor="t" lIns="27432" rIns="27432" tIns="18288" bIns="18288">
+          <a:bodyPr wrap="square" lIns="27432" tIns="18288" rIns="27432" bIns="18288" anchor="t">
             <a:spAutoFit/>
           </a:bodyPr>
           <a:lstStyle/>
@@ -3272,7 +3274,7 @@
           <a:noFill/>
         </p:spPr>
         <p:txBody>
-          <a:bodyPr wrap="square" anchor="t" lIns="27432" rIns="27432" tIns="18288" bIns="18288">
+          <a:bodyPr wrap="square" lIns="27432" tIns="18288" rIns="27432" bIns="18288" anchor="t">
             <a:spAutoFit/>
           </a:bodyPr>
           <a:lstStyle/>
@@ -3311,7 +3313,7 @@
           <a:noFill/>
         </p:spPr>
         <p:txBody>
-          <a:bodyPr wrap="square" anchor="t" lIns="27432" rIns="27432" tIns="18288" bIns="18288">
+          <a:bodyPr wrap="square" lIns="27432" tIns="18288" rIns="27432" bIns="18288" anchor="t">
             <a:spAutoFit/>
           </a:bodyPr>
           <a:lstStyle/>
@@ -3350,7 +3352,7 @@
           <a:noFill/>
         </p:spPr>
         <p:txBody>
-          <a:bodyPr wrap="square" anchor="t" lIns="27432" rIns="27432" tIns="18288" bIns="18288">
+          <a:bodyPr wrap="square" lIns="27432" tIns="18288" rIns="27432" bIns="18288" anchor="t">
             <a:spAutoFit/>
           </a:bodyPr>
           <a:lstStyle/>
@@ -3381,7 +3383,7 @@
 </file>
 
 <file path=ppt/slides/slide2.xml><?xml version="1.0" encoding="utf-8"?>
-<p:sld xmlns:a="http://schemas.openxmlformats.org/drawingml/2006/main" xmlns:p="http://schemas.openxmlformats.org/presentationml/2006/main" xmlns:r="http://schemas.openxmlformats.org/officeDocument/2006/relationships">
+<p:sld xmlns:a="http://schemas.openxmlformats.org/drawingml/2006/main" xmlns:r="http://schemas.openxmlformats.org/officeDocument/2006/relationships" xmlns:p="http://schemas.openxmlformats.org/presentationml/2006/main">
   <p:cSld>
     <p:bg>
       <p:bgPr>
@@ -3397,7 +3399,14 @@
         <p:cNvGrpSpPr/>
         <p:nvPr/>
       </p:nvGrpSpPr>
-      <p:grpSpPr/>
+      <p:grpSpPr>
+        <a:xfrm>
+          <a:off x="0" y="0"/>
+          <a:ext cx="0" cy="0"/>
+          <a:chOff x="0" y="0"/>
+          <a:chExt cx="0" cy="0"/>
+        </a:xfrm>
+      </p:grpSpPr>
       <p:sp>
         <p:nvSpPr>
           <p:cNvPr id="2" name="TextBox 1"/>
@@ -3415,7 +3424,7 @@
           <a:noFill/>
         </p:spPr>
         <p:txBody>
-          <a:bodyPr wrap="square" anchor="t" lIns="27432" rIns="27432" tIns="18288" bIns="18288">
+          <a:bodyPr wrap="square" lIns="27432" tIns="18288" rIns="27432" bIns="18288" anchor="t">
             <a:spAutoFit/>
           </a:bodyPr>
           <a:lstStyle/>
@@ -3454,7 +3463,7 @@
           <a:noFill/>
         </p:spPr>
         <p:txBody>
-          <a:bodyPr wrap="square" anchor="t" lIns="27432" rIns="27432" tIns="18288" bIns="18288">
+          <a:bodyPr wrap="square" lIns="27432" tIns="18288" rIns="27432" bIns="18288" anchor="t">
             <a:spAutoFit/>
           </a:bodyPr>
           <a:lstStyle/>
@@ -3493,7 +3502,7 @@
           <a:noFill/>
         </p:spPr>
         <p:txBody>
-          <a:bodyPr wrap="square" anchor="t" lIns="27432" rIns="27432" tIns="18288" bIns="18288">
+          <a:bodyPr wrap="square" lIns="27432" tIns="18288" rIns="27432" bIns="18288" anchor="t">
             <a:spAutoFit/>
           </a:bodyPr>
           <a:lstStyle/>
@@ -3523,7 +3532,7 @@
         </p:nvSpPr>
         <p:spPr>
           <a:xfrm>
-            <a:off x="502920" y="6510528"/>
+            <a:off x="502920" y="6629400"/>
             <a:ext cx="4572000" cy="274320"/>
           </a:xfrm>
           <a:prstGeom prst="rect">
@@ -3532,7 +3541,7 @@
           <a:noFill/>
         </p:spPr>
         <p:txBody>
-          <a:bodyPr wrap="square" anchor="t" lIns="27432" rIns="27432" tIns="18288" bIns="18288">
+          <a:bodyPr wrap="square" lIns="27432" tIns="18288" rIns="27432" bIns="18288" anchor="t">
             <a:spAutoFit/>
           </a:bodyPr>
           <a:lstStyle/>
@@ -3543,7 +3552,7 @@
               </a:lnSpc>
             </a:pPr>
             <a:r>
-              <a:rPr sz="1000" b="0">
+              <a:rPr sz="1000" b="0" dirty="0">
                 <a:solidFill>
                   <a:srgbClr val="6E6A60"/>
                 </a:solidFill>
@@ -3597,19 +3606,34 @@
           <a:p>
             <a:pPr algn="ctr" latinLnBrk="0"/>
             <a:r>
-              <a:rPr sz="1900" b="1">
+              <a:rPr sz="1900" b="1" dirty="0">
                 <a:solidFill>
                   <a:srgbClr val="FDFBF5"/>
                 </a:solidFill>
                 <a:latin typeface="Segoe UI Semibold"/>
               </a:rPr>
-              <a:t>E(t)  =  mean(  A(t) audio,  V(t) visual,  N(t) network  )</a:t>
-            </a:r>
+              <a:t>E(t) = mean(A(t) audio, V(t) visual, N(t) network)</a:t>
+            </a:r>
+            <a:endParaRPr lang="en-GB" sz="1900" b="1" dirty="0">
+              <a:solidFill>
+                <a:srgbClr val="FDFBF5"/>
+              </a:solidFill>
+              <a:latin typeface="Segoe UI Semibold"/>
+            </a:endParaRPr>
           </a:p>
           <a:p>
             <a:pPr algn="ctr" latinLnBrk="0"/>
-            <a:r>
-              <a:rPr sz="1200" b="0">
+            <a:endParaRPr sz="1900" b="1" dirty="0">
+              <a:solidFill>
+                <a:srgbClr val="FDFBF5"/>
+              </a:solidFill>
+              <a:latin typeface="Segoe UI Semibold"/>
+            </a:endParaRPr>
+          </a:p>
+          <a:p>
+            <a:pPr algn="ctr" latinLnBrk="0"/>
+            <a:r>
+              <a:rPr sz="1200" b="0" dirty="0">
                 <a:solidFill>
                   <a:srgbClr val="CBD9DD"/>
                 </a:solidFill>
@@ -3660,7 +3684,7 @@
           </a:fontRef>
         </p:style>
         <p:txBody>
-          <a:bodyPr rtlCol="0" anchor="t" wrap="square" lIns="201168" rIns="201168" tIns="146304"/>
+          <a:bodyPr wrap="square" lIns="201168" tIns="146304" rIns="201168" rtlCol="0" anchor="t"/>
           <a:lstStyle/>
           <a:p>
             <a:pPr algn="l" latinLnBrk="0">
@@ -3736,7 +3760,7 @@
           </a:fontRef>
         </p:style>
         <p:txBody>
-          <a:bodyPr rtlCol="0" anchor="t" wrap="square" lIns="201168" rIns="201168" tIns="146304"/>
+          <a:bodyPr wrap="square" lIns="201168" tIns="146304" rIns="201168" rtlCol="0" anchor="t"/>
           <a:lstStyle/>
           <a:p>
             <a:pPr algn="l" latinLnBrk="0">
@@ -3812,7 +3836,7 @@
           </a:fontRef>
         </p:style>
         <p:txBody>
-          <a:bodyPr rtlCol="0" anchor="t" wrap="square" lIns="201168" rIns="201168" tIns="146304"/>
+          <a:bodyPr wrap="square" lIns="201168" tIns="146304" rIns="201168" rtlCol="0" anchor="t"/>
           <a:lstStyle/>
           <a:p>
             <a:pPr algn="l" latinLnBrk="0">
@@ -3865,7 +3889,7 @@
           <a:noFill/>
         </p:spPr>
         <p:txBody>
-          <a:bodyPr wrap="square" anchor="t" lIns="27432" rIns="27432" tIns="18288" bIns="18288">
+          <a:bodyPr wrap="square" lIns="27432" tIns="18288" rIns="27432" bIns="18288" anchor="t">
             <a:spAutoFit/>
           </a:bodyPr>
           <a:lstStyle/>
@@ -3927,6 +3951,7 @@
           <a:lstStyle/>
           <a:p>
             <a:pPr algn="ctr"/>
+            <a:endParaRPr/>
           </a:p>
         </p:txBody>
       </p:sp>
@@ -3947,7 +3972,7 @@
           <a:noFill/>
         </p:spPr>
         <p:txBody>
-          <a:bodyPr wrap="square" anchor="t" lIns="27432" rIns="27432" tIns="18288" bIns="18288">
+          <a:bodyPr wrap="square" lIns="27432" tIns="18288" rIns="27432" bIns="18288" anchor="t">
             <a:spAutoFit/>
           </a:bodyPr>
           <a:lstStyle/>
@@ -3986,7 +4011,7 @@
           <a:noFill/>
         </p:spPr>
         <p:txBody>
-          <a:bodyPr wrap="square" anchor="t" lIns="27432" rIns="27432" tIns="18288" bIns="18288">
+          <a:bodyPr wrap="square" lIns="27432" tIns="18288" rIns="27432" bIns="18288" anchor="t">
             <a:spAutoFit/>
           </a:bodyPr>
           <a:lstStyle/>
@@ -4048,6 +4073,7 @@
           <a:lstStyle/>
           <a:p>
             <a:pPr algn="ctr"/>
+            <a:endParaRPr/>
           </a:p>
         </p:txBody>
       </p:sp>
@@ -4068,7 +4094,7 @@
           <a:noFill/>
         </p:spPr>
         <p:txBody>
-          <a:bodyPr wrap="square" anchor="t" lIns="27432" rIns="27432" tIns="18288" bIns="18288">
+          <a:bodyPr wrap="square" lIns="27432" tIns="18288" rIns="27432" bIns="18288" anchor="t">
             <a:spAutoFit/>
           </a:bodyPr>
           <a:lstStyle/>
@@ -4107,7 +4133,7 @@
           <a:noFill/>
         </p:spPr>
         <p:txBody>
-          <a:bodyPr wrap="square" anchor="t" lIns="27432" rIns="27432" tIns="18288" bIns="18288">
+          <a:bodyPr wrap="square" lIns="27432" tIns="18288" rIns="27432" bIns="18288" anchor="t">
             <a:spAutoFit/>
           </a:bodyPr>
           <a:lstStyle/>
@@ -4169,6 +4195,7 @@
           <a:lstStyle/>
           <a:p>
             <a:pPr algn="ctr"/>
+            <a:endParaRPr/>
           </a:p>
         </p:txBody>
       </p:sp>
@@ -4189,7 +4216,7 @@
           <a:noFill/>
         </p:spPr>
         <p:txBody>
-          <a:bodyPr wrap="square" anchor="t" lIns="27432" rIns="27432" tIns="18288" bIns="18288">
+          <a:bodyPr wrap="square" lIns="27432" tIns="18288" rIns="27432" bIns="18288" anchor="t">
             <a:spAutoFit/>
           </a:bodyPr>
           <a:lstStyle/>
@@ -4228,7 +4255,7 @@
           <a:noFill/>
         </p:spPr>
         <p:txBody>
-          <a:bodyPr wrap="square" anchor="t" lIns="27432" rIns="27432" tIns="18288" bIns="18288">
+          <a:bodyPr wrap="square" lIns="27432" tIns="18288" rIns="27432" bIns="18288" anchor="t">
             <a:spAutoFit/>
           </a:bodyPr>
           <a:lstStyle/>
@@ -4290,6 +4317,7 @@
           <a:lstStyle/>
           <a:p>
             <a:pPr algn="ctr"/>
+            <a:endParaRPr/>
           </a:p>
         </p:txBody>
       </p:sp>
@@ -4310,7 +4338,7 @@
           <a:noFill/>
         </p:spPr>
         <p:txBody>
-          <a:bodyPr wrap="square" anchor="t" lIns="27432" rIns="27432" tIns="18288" bIns="18288">
+          <a:bodyPr wrap="square" lIns="27432" tIns="18288" rIns="27432" bIns="18288" anchor="t">
             <a:spAutoFit/>
           </a:bodyPr>
           <a:lstStyle/>
@@ -4349,7 +4377,7 @@
           <a:noFill/>
         </p:spPr>
         <p:txBody>
-          <a:bodyPr wrap="square" anchor="t" lIns="27432" rIns="27432" tIns="18288" bIns="18288">
+          <a:bodyPr wrap="square" lIns="27432" tIns="18288" rIns="27432" bIns="18288" anchor="t">
             <a:spAutoFit/>
           </a:bodyPr>
           <a:lstStyle/>
@@ -4411,6 +4439,7 @@
           <a:lstStyle/>
           <a:p>
             <a:pPr algn="ctr"/>
+            <a:endParaRPr/>
           </a:p>
         </p:txBody>
       </p:sp>
@@ -4431,7 +4460,7 @@
           <a:noFill/>
         </p:spPr>
         <p:txBody>
-          <a:bodyPr wrap="square" anchor="t" lIns="27432" rIns="27432" tIns="18288" bIns="18288">
+          <a:bodyPr wrap="square" lIns="27432" tIns="18288" rIns="27432" bIns="18288" anchor="t">
             <a:spAutoFit/>
           </a:bodyPr>
           <a:lstStyle/>
@@ -4470,7 +4499,7 @@
           <a:noFill/>
         </p:spPr>
         <p:txBody>
-          <a:bodyPr wrap="square" anchor="t" lIns="27432" rIns="27432" tIns="18288" bIns="18288">
+          <a:bodyPr wrap="square" lIns="27432" tIns="18288" rIns="27432" bIns="18288" anchor="t">
             <a:spAutoFit/>
           </a:bodyPr>
           <a:lstStyle/>
@@ -4532,6 +4561,7 @@
           <a:lstStyle/>
           <a:p>
             <a:pPr algn="ctr"/>
+            <a:endParaRPr/>
           </a:p>
         </p:txBody>
       </p:sp>
@@ -4552,7 +4582,7 @@
           <a:noFill/>
         </p:spPr>
         <p:txBody>
-          <a:bodyPr wrap="square" anchor="t" lIns="27432" rIns="27432" tIns="18288" bIns="18288">
+          <a:bodyPr wrap="square" lIns="27432" tIns="18288" rIns="27432" bIns="18288" anchor="t">
             <a:spAutoFit/>
           </a:bodyPr>
           <a:lstStyle/>
@@ -4591,7 +4621,7 @@
           <a:noFill/>
         </p:spPr>
         <p:txBody>
-          <a:bodyPr wrap="square" anchor="t" lIns="27432" rIns="27432" tIns="18288" bIns="18288">
+          <a:bodyPr wrap="square" lIns="27432" tIns="18288" rIns="27432" bIns="18288" anchor="t">
             <a:spAutoFit/>
           </a:bodyPr>
           <a:lstStyle/>
@@ -4653,6 +4683,7 @@
           <a:lstStyle/>
           <a:p>
             <a:pPr algn="ctr"/>
+            <a:endParaRPr/>
           </a:p>
         </p:txBody>
       </p:sp>
@@ -4673,7 +4704,7 @@
           <a:noFill/>
         </p:spPr>
         <p:txBody>
-          <a:bodyPr wrap="square" anchor="t" lIns="27432" rIns="27432" tIns="18288" bIns="18288">
+          <a:bodyPr wrap="square" lIns="27432" tIns="18288" rIns="27432" bIns="18288" anchor="t">
             <a:spAutoFit/>
           </a:bodyPr>
           <a:lstStyle/>
@@ -4712,7 +4743,7 @@
           <a:noFill/>
         </p:spPr>
         <p:txBody>
-          <a:bodyPr wrap="square" anchor="t" lIns="27432" rIns="27432" tIns="18288" bIns="18288">
+          <a:bodyPr wrap="square" lIns="27432" tIns="18288" rIns="27432" bIns="18288" anchor="t">
             <a:spAutoFit/>
           </a:bodyPr>
           <a:lstStyle/>
@@ -4772,7 +4803,7 @@
           </a:fontRef>
         </p:style>
         <p:txBody>
-          <a:bodyPr rtlCol="0" anchor="ctr" wrap="square"/>
+          <a:bodyPr wrap="square" rtlCol="0" anchor="ctr"/>
           <a:lstStyle/>
           <a:p>
             <a:pPr algn="ctr" latinLnBrk="0"/>
@@ -4797,7 +4828,7 @@
 </file>
 
 <file path=ppt/slides/slide3.xml><?xml version="1.0" encoding="utf-8"?>
-<p:sld xmlns:a="http://schemas.openxmlformats.org/drawingml/2006/main" xmlns:p="http://schemas.openxmlformats.org/presentationml/2006/main" xmlns:r="http://schemas.openxmlformats.org/officeDocument/2006/relationships">
+<p:sld xmlns:a="http://schemas.openxmlformats.org/drawingml/2006/main" xmlns:r="http://schemas.openxmlformats.org/officeDocument/2006/relationships" xmlns:p="http://schemas.openxmlformats.org/presentationml/2006/main">
   <p:cSld>
     <p:bg>
       <p:bgPr>
@@ -4813,7 +4844,14 @@
         <p:cNvGrpSpPr/>
         <p:nvPr/>
       </p:nvGrpSpPr>
-      <p:grpSpPr/>
+      <p:grpSpPr>
+        <a:xfrm>
+          <a:off x="0" y="0"/>
+          <a:ext cx="0" cy="0"/>
+          <a:chOff x="0" y="0"/>
+          <a:chExt cx="0" cy="0"/>
+        </a:xfrm>
+      </p:grpSpPr>
       <p:sp>
         <p:nvSpPr>
           <p:cNvPr id="2" name="TextBox 1"/>
@@ -4831,7 +4869,7 @@
           <a:noFill/>
         </p:spPr>
         <p:txBody>
-          <a:bodyPr wrap="square" anchor="t" lIns="27432" rIns="27432" tIns="18288" bIns="18288">
+          <a:bodyPr wrap="square" lIns="27432" tIns="18288" rIns="27432" bIns="18288" anchor="t">
             <a:spAutoFit/>
           </a:bodyPr>
           <a:lstStyle/>
@@ -4870,7 +4908,7 @@
           <a:noFill/>
         </p:spPr>
         <p:txBody>
-          <a:bodyPr wrap="square" anchor="t" lIns="27432" rIns="27432" tIns="18288" bIns="18288">
+          <a:bodyPr wrap="square" lIns="27432" tIns="18288" rIns="27432" bIns="18288" anchor="t">
             <a:spAutoFit/>
           </a:bodyPr>
           <a:lstStyle/>
@@ -4909,7 +4947,7 @@
           <a:noFill/>
         </p:spPr>
         <p:txBody>
-          <a:bodyPr wrap="square" anchor="t" lIns="27432" rIns="27432" tIns="18288" bIns="18288">
+          <a:bodyPr wrap="square" lIns="27432" tIns="18288" rIns="27432" bIns="18288" anchor="t">
             <a:spAutoFit/>
           </a:bodyPr>
           <a:lstStyle/>
@@ -4939,7 +4977,7 @@
         </p:nvSpPr>
         <p:spPr>
           <a:xfrm>
-            <a:off x="502920" y="6510528"/>
+            <a:off x="502920" y="6629400"/>
             <a:ext cx="4572000" cy="274320"/>
           </a:xfrm>
           <a:prstGeom prst="rect">
@@ -4948,7 +4986,7 @@
           <a:noFill/>
         </p:spPr>
         <p:txBody>
-          <a:bodyPr wrap="square" anchor="t" lIns="27432" rIns="27432" tIns="18288" bIns="18288">
+          <a:bodyPr wrap="square" lIns="27432" tIns="18288" rIns="27432" bIns="18288" anchor="t">
             <a:spAutoFit/>
           </a:bodyPr>
           <a:lstStyle/>
@@ -4959,7 +4997,7 @@
               </a:lnSpc>
             </a:pPr>
             <a:r>
-              <a:rPr sz="1000" b="0">
+              <a:rPr sz="1000" b="0" dirty="0">
                 <a:solidFill>
                   <a:srgbClr val="6E6A60"/>
                 </a:solidFill>
@@ -5034,7 +5072,7 @@
           </a:fontRef>
         </p:style>
         <p:txBody>
-          <a:bodyPr rtlCol="0" anchor="ctr" wrap="square"/>
+          <a:bodyPr wrap="square" rtlCol="0" anchor="ctr"/>
           <a:lstStyle/>
           <a:p>
             <a:pPr algn="ctr" latinLnBrk="0"/>
@@ -5102,7 +5140,7 @@
           </a:fontRef>
         </p:style>
         <p:txBody>
-          <a:bodyPr rtlCol="0" anchor="ctr" wrap="square"/>
+          <a:bodyPr wrap="square" rtlCol="0" anchor="ctr"/>
           <a:lstStyle/>
           <a:p>
             <a:pPr algn="ctr" latinLnBrk="0"/>
@@ -5170,7 +5208,7 @@
           </a:fontRef>
         </p:style>
         <p:txBody>
-          <a:bodyPr rtlCol="0" anchor="ctr" wrap="square"/>
+          <a:bodyPr wrap="square" rtlCol="0" anchor="ctr"/>
           <a:lstStyle/>
           <a:p>
             <a:pPr algn="ctr" latinLnBrk="0"/>
@@ -5215,7 +5253,7 @@
           <a:noFill/>
         </p:spPr>
         <p:txBody>
-          <a:bodyPr wrap="square" anchor="t" lIns="27432" rIns="27432" tIns="18288" bIns="18288">
+          <a:bodyPr wrap="square" lIns="27432" tIns="18288" rIns="27432" bIns="18288" anchor="t">
             <a:spAutoFit/>
           </a:bodyPr>
           <a:lstStyle/>
@@ -5275,7 +5313,7 @@
           </a:fontRef>
         </p:style>
         <p:txBody>
-          <a:bodyPr rtlCol="0" anchor="ctr" wrap="square"/>
+          <a:bodyPr wrap="square" rtlCol="0" anchor="ctr"/>
           <a:lstStyle/>
           <a:p>
             <a:pPr algn="ctr" latinLnBrk="0"/>
@@ -5300,7 +5338,7 @@
 </file>
 
 <file path=ppt/slides/slide4.xml><?xml version="1.0" encoding="utf-8"?>
-<p:sld xmlns:a="http://schemas.openxmlformats.org/drawingml/2006/main" xmlns:p="http://schemas.openxmlformats.org/presentationml/2006/main" xmlns:r="http://schemas.openxmlformats.org/officeDocument/2006/relationships">
+<p:sld xmlns:a="http://schemas.openxmlformats.org/drawingml/2006/main" xmlns:r="http://schemas.openxmlformats.org/officeDocument/2006/relationships" xmlns:p="http://schemas.openxmlformats.org/presentationml/2006/main">
   <p:cSld>
     <p:bg>
       <p:bgPr>
@@ -5316,7 +5354,14 @@
         <p:cNvGrpSpPr/>
         <p:nvPr/>
       </p:nvGrpSpPr>
-      <p:grpSpPr/>
+      <p:grpSpPr>
+        <a:xfrm>
+          <a:off x="0" y="0"/>
+          <a:ext cx="0" cy="0"/>
+          <a:chOff x="0" y="0"/>
+          <a:chExt cx="0" cy="0"/>
+        </a:xfrm>
+      </p:grpSpPr>
       <p:sp>
         <p:nvSpPr>
           <p:cNvPr id="2" name="TextBox 1"/>
@@ -5334,7 +5379,7 @@
           <a:noFill/>
         </p:spPr>
         <p:txBody>
-          <a:bodyPr wrap="square" anchor="t" lIns="27432" rIns="27432" tIns="18288" bIns="18288">
+          <a:bodyPr wrap="square" lIns="27432" tIns="18288" rIns="27432" bIns="18288" anchor="t">
             <a:spAutoFit/>
           </a:bodyPr>
           <a:lstStyle/>
@@ -5373,7 +5418,7 @@
           <a:noFill/>
         </p:spPr>
         <p:txBody>
-          <a:bodyPr wrap="square" anchor="t" lIns="27432" rIns="27432" tIns="18288" bIns="18288">
+          <a:bodyPr wrap="square" lIns="27432" tIns="18288" rIns="27432" bIns="18288" anchor="t">
             <a:spAutoFit/>
           </a:bodyPr>
           <a:lstStyle/>
@@ -5412,7 +5457,7 @@
           <a:noFill/>
         </p:spPr>
         <p:txBody>
-          <a:bodyPr wrap="square" anchor="t" lIns="27432" rIns="27432" tIns="18288" bIns="18288">
+          <a:bodyPr wrap="square" lIns="27432" tIns="18288" rIns="27432" bIns="18288" anchor="t">
             <a:spAutoFit/>
           </a:bodyPr>
           <a:lstStyle/>
@@ -5442,7 +5487,7 @@
         </p:nvSpPr>
         <p:spPr>
           <a:xfrm>
-            <a:off x="502920" y="6510528"/>
+            <a:off x="502920" y="6620256"/>
             <a:ext cx="4572000" cy="274320"/>
           </a:xfrm>
           <a:prstGeom prst="rect">
@@ -5451,7 +5496,7 @@
           <a:noFill/>
         </p:spPr>
         <p:txBody>
-          <a:bodyPr wrap="square" anchor="t" lIns="27432" rIns="27432" tIns="18288" bIns="18288">
+          <a:bodyPr wrap="square" lIns="27432" tIns="18288" rIns="27432" bIns="18288" anchor="t">
             <a:spAutoFit/>
           </a:bodyPr>
           <a:lstStyle/>
@@ -5537,7 +5582,7 @@
           </a:fontRef>
         </p:style>
         <p:txBody>
-          <a:bodyPr rtlCol="0" anchor="ctr" wrap="square"/>
+          <a:bodyPr wrap="square" rtlCol="0" anchor="ctr"/>
           <a:lstStyle/>
           <a:p>
             <a:pPr algn="ctr" latinLnBrk="0"/>
@@ -5605,7 +5650,7 @@
           </a:fontRef>
         </p:style>
         <p:txBody>
-          <a:bodyPr rtlCol="0" anchor="ctr" wrap="square"/>
+          <a:bodyPr wrap="square" rtlCol="0" anchor="ctr"/>
           <a:lstStyle/>
           <a:p>
             <a:pPr algn="ctr" latinLnBrk="0"/>
@@ -5673,7 +5718,7 @@
           </a:fontRef>
         </p:style>
         <p:txBody>
-          <a:bodyPr rtlCol="0" anchor="ctr" wrap="square"/>
+          <a:bodyPr wrap="square" rtlCol="0" anchor="ctr"/>
           <a:lstStyle/>
           <a:p>
             <a:pPr algn="ctr" latinLnBrk="0"/>
@@ -5718,7 +5763,7 @@
           <a:noFill/>
         </p:spPr>
         <p:txBody>
-          <a:bodyPr wrap="square" anchor="t" lIns="27432" rIns="27432" tIns="18288" bIns="18288">
+          <a:bodyPr wrap="square" lIns="27432" tIns="18288" rIns="27432" bIns="18288" anchor="t">
             <a:spAutoFit/>
           </a:bodyPr>
           <a:lstStyle/>
@@ -5778,7 +5823,7 @@
           </a:fontRef>
         </p:style>
         <p:txBody>
-          <a:bodyPr rtlCol="0" anchor="ctr" wrap="square"/>
+          <a:bodyPr wrap="square" rtlCol="0" anchor="ctr"/>
           <a:lstStyle/>
           <a:p>
             <a:pPr algn="ctr" latinLnBrk="0"/>
@@ -5803,7 +5848,7 @@
 </file>
 
 <file path=ppt/slides/slide5.xml><?xml version="1.0" encoding="utf-8"?>
-<p:sld xmlns:a="http://schemas.openxmlformats.org/drawingml/2006/main" xmlns:p="http://schemas.openxmlformats.org/presentationml/2006/main" xmlns:r="http://schemas.openxmlformats.org/officeDocument/2006/relationships">
+<p:sld xmlns:a="http://schemas.openxmlformats.org/drawingml/2006/main" xmlns:r="http://schemas.openxmlformats.org/officeDocument/2006/relationships" xmlns:p="http://schemas.openxmlformats.org/presentationml/2006/main">
   <p:cSld>
     <p:bg>
       <p:bgPr>
@@ -5819,7 +5864,14 @@
         <p:cNvGrpSpPr/>
         <p:nvPr/>
       </p:nvGrpSpPr>
-      <p:grpSpPr/>
+      <p:grpSpPr>
+        <a:xfrm>
+          <a:off x="0" y="0"/>
+          <a:ext cx="0" cy="0"/>
+          <a:chOff x="0" y="0"/>
+          <a:chExt cx="0" cy="0"/>
+        </a:xfrm>
+      </p:grpSpPr>
       <p:sp>
         <p:nvSpPr>
           <p:cNvPr id="2" name="TextBox 1"/>
@@ -5837,7 +5889,7 @@
           <a:noFill/>
         </p:spPr>
         <p:txBody>
-          <a:bodyPr wrap="square" anchor="t" lIns="27432" rIns="27432" tIns="18288" bIns="18288">
+          <a:bodyPr wrap="square" lIns="27432" tIns="18288" rIns="27432" bIns="18288" anchor="t">
             <a:spAutoFit/>
           </a:bodyPr>
           <a:lstStyle/>
@@ -5876,7 +5928,7 @@
           <a:noFill/>
         </p:spPr>
         <p:txBody>
-          <a:bodyPr wrap="square" anchor="t" lIns="27432" rIns="27432" tIns="18288" bIns="18288">
+          <a:bodyPr wrap="square" lIns="27432" tIns="18288" rIns="27432" bIns="18288" anchor="t">
             <a:spAutoFit/>
           </a:bodyPr>
           <a:lstStyle/>
@@ -5915,7 +5967,7 @@
           <a:noFill/>
         </p:spPr>
         <p:txBody>
-          <a:bodyPr wrap="square" anchor="t" lIns="27432" rIns="27432" tIns="18288" bIns="18288">
+          <a:bodyPr wrap="square" lIns="27432" tIns="18288" rIns="27432" bIns="18288" anchor="t">
             <a:spAutoFit/>
           </a:bodyPr>
           <a:lstStyle/>
@@ -5945,7 +5997,7 @@
         </p:nvSpPr>
         <p:spPr>
           <a:xfrm>
-            <a:off x="502920" y="6510528"/>
+            <a:off x="502920" y="6638544"/>
             <a:ext cx="4572000" cy="274320"/>
           </a:xfrm>
           <a:prstGeom prst="rect">
@@ -5954,7 +6006,7 @@
           <a:noFill/>
         </p:spPr>
         <p:txBody>
-          <a:bodyPr wrap="square" anchor="t" lIns="27432" rIns="27432" tIns="18288" bIns="18288">
+          <a:bodyPr wrap="square" lIns="27432" tIns="18288" rIns="27432" bIns="18288" anchor="t">
             <a:spAutoFit/>
           </a:bodyPr>
           <a:lstStyle/>
@@ -5965,7 +6017,7 @@
               </a:lnSpc>
             </a:pPr>
             <a:r>
-              <a:rPr sz="1000" b="0">
+              <a:rPr sz="1000" b="0" dirty="0">
                 <a:solidFill>
                   <a:srgbClr val="6E6A60"/>
                 </a:solidFill>
@@ -6064,7 +6116,7 @@
           </a:fontRef>
         </p:style>
         <p:txBody>
-          <a:bodyPr rtlCol="0" anchor="ctr" wrap="square"/>
+          <a:bodyPr wrap="square" rtlCol="0" anchor="ctr"/>
           <a:lstStyle/>
           <a:p>
             <a:pPr algn="ctr" latinLnBrk="0"/>
@@ -6132,7 +6184,7 @@
           </a:fontRef>
         </p:style>
         <p:txBody>
-          <a:bodyPr rtlCol="0" anchor="ctr" wrap="square"/>
+          <a:bodyPr wrap="square" rtlCol="0" anchor="ctr"/>
           <a:lstStyle/>
           <a:p>
             <a:pPr algn="ctr" latinLnBrk="0"/>
@@ -6200,7 +6252,7 @@
           </a:fontRef>
         </p:style>
         <p:txBody>
-          <a:bodyPr rtlCol="0" anchor="ctr" wrap="square"/>
+          <a:bodyPr wrap="square" rtlCol="0" anchor="ctr"/>
           <a:lstStyle/>
           <a:p>
             <a:pPr algn="ctr" latinLnBrk="0"/>
@@ -6321,7 +6373,7 @@
           </a:fontRef>
         </p:style>
         <p:txBody>
-          <a:bodyPr rtlCol="0" anchor="ctr" wrap="square"/>
+          <a:bodyPr wrap="square" rtlCol="0" anchor="ctr"/>
           <a:lstStyle/>
           <a:p>
             <a:pPr algn="ctr" latinLnBrk="0"/>
@@ -6346,7 +6398,7 @@
 </file>
 
 <file path=ppt/slides/slide6.xml><?xml version="1.0" encoding="utf-8"?>
-<p:sld xmlns:a="http://schemas.openxmlformats.org/drawingml/2006/main" xmlns:p="http://schemas.openxmlformats.org/presentationml/2006/main" xmlns:r="http://schemas.openxmlformats.org/officeDocument/2006/relationships">
+<p:sld xmlns:a="http://schemas.openxmlformats.org/drawingml/2006/main" xmlns:r="http://schemas.openxmlformats.org/officeDocument/2006/relationships" xmlns:p="http://schemas.openxmlformats.org/presentationml/2006/main">
   <p:cSld>
     <p:bg>
       <p:bgPr>
@@ -6362,7 +6414,14 @@
         <p:cNvGrpSpPr/>
         <p:nvPr/>
       </p:nvGrpSpPr>
-      <p:grpSpPr/>
+      <p:grpSpPr>
+        <a:xfrm>
+          <a:off x="0" y="0"/>
+          <a:ext cx="0" cy="0"/>
+          <a:chOff x="0" y="0"/>
+          <a:chExt cx="0" cy="0"/>
+        </a:xfrm>
+      </p:grpSpPr>
       <p:sp>
         <p:nvSpPr>
           <p:cNvPr id="2" name="TextBox 1"/>
@@ -6380,7 +6439,7 @@
           <a:noFill/>
         </p:spPr>
         <p:txBody>
-          <a:bodyPr wrap="square" anchor="t" lIns="27432" rIns="27432" tIns="18288" bIns="18288">
+          <a:bodyPr wrap="square" lIns="27432" tIns="18288" rIns="27432" bIns="18288" anchor="t">
             <a:spAutoFit/>
           </a:bodyPr>
           <a:lstStyle/>
@@ -6419,7 +6478,7 @@
           <a:noFill/>
         </p:spPr>
         <p:txBody>
-          <a:bodyPr wrap="square" anchor="t" lIns="27432" rIns="27432" tIns="18288" bIns="18288">
+          <a:bodyPr wrap="square" lIns="27432" tIns="18288" rIns="27432" bIns="18288" anchor="t">
             <a:spAutoFit/>
           </a:bodyPr>
           <a:lstStyle/>
@@ -6458,7 +6517,7 @@
           <a:noFill/>
         </p:spPr>
         <p:txBody>
-          <a:bodyPr wrap="square" anchor="t" lIns="27432" rIns="27432" tIns="18288" bIns="18288">
+          <a:bodyPr wrap="square" lIns="27432" tIns="18288" rIns="27432" bIns="18288" anchor="t">
             <a:spAutoFit/>
           </a:bodyPr>
           <a:lstStyle/>
@@ -6488,7 +6547,7 @@
         </p:nvSpPr>
         <p:spPr>
           <a:xfrm>
-            <a:off x="502920" y="6510528"/>
+            <a:off x="502920" y="6629400"/>
             <a:ext cx="4572000" cy="274320"/>
           </a:xfrm>
           <a:prstGeom prst="rect">
@@ -6497,7 +6556,7 @@
           <a:noFill/>
         </p:spPr>
         <p:txBody>
-          <a:bodyPr wrap="square" anchor="t" lIns="27432" rIns="27432" tIns="18288" bIns="18288">
+          <a:bodyPr wrap="square" lIns="27432" tIns="18288" rIns="27432" bIns="18288" anchor="t">
             <a:spAutoFit/>
           </a:bodyPr>
           <a:lstStyle/>
@@ -6508,7 +6567,7 @@
               </a:lnSpc>
             </a:pPr>
             <a:r>
-              <a:rPr sz="1000" b="0">
+              <a:rPr sz="1000" b="0" dirty="0">
                 <a:solidFill>
                   <a:srgbClr val="6E6A60"/>
                 </a:solidFill>
@@ -6538,8 +6597,20 @@
                 <a:tableStyleId>{5C22544A-7EE6-4342-B048-85BDC9FD1C3A}</a:tableStyleId>
               </a:tblPr>
               <a:tblGrid>
-                <a:gridCol w="2377440"/>
-                <a:gridCol w="8778240"/>
+                <a:gridCol w="2377440">
+                  <a:extLst>
+                    <a:ext uri="{9D8B030D-6E8A-4147-A177-3AD203B41FA5}">
+                      <a16:colId xmlns:a16="http://schemas.microsoft.com/office/drawing/2014/main" val="20000"/>
+                    </a:ext>
+                  </a:extLst>
+                </a:gridCol>
+                <a:gridCol w="8778240">
+                  <a:extLst>
+                    <a:ext uri="{9D8B030D-6E8A-4147-A177-3AD203B41FA5}">
+                      <a16:colId xmlns:a16="http://schemas.microsoft.com/office/drawing/2014/main" val="20001"/>
+                    </a:ext>
+                  </a:extLst>
+                </a:gridCol>
               </a:tblGrid>
               <a:tr h="655320">
                 <a:tc>
@@ -6588,6 +6659,11 @@
                     </a:solidFill>
                   </a:tcPr>
                 </a:tc>
+                <a:extLst>
+                  <a:ext uri="{0D108BD9-81ED-4DB2-BD59-A6C34878D82A}">
+                    <a16:rowId xmlns:a16="http://schemas.microsoft.com/office/drawing/2014/main" val="10000"/>
+                  </a:ext>
+                </a:extLst>
               </a:tr>
               <a:tr h="655320">
                 <a:tc>
@@ -6636,6 +6712,11 @@
                     </a:solidFill>
                   </a:tcPr>
                 </a:tc>
+                <a:extLst>
+                  <a:ext uri="{0D108BD9-81ED-4DB2-BD59-A6C34878D82A}">
+                    <a16:rowId xmlns:a16="http://schemas.microsoft.com/office/drawing/2014/main" val="10001"/>
+                  </a:ext>
+                </a:extLst>
               </a:tr>
               <a:tr h="655320">
                 <a:tc>
@@ -6684,6 +6765,11 @@
                     </a:solidFill>
                   </a:tcPr>
                 </a:tc>
+                <a:extLst>
+                  <a:ext uri="{0D108BD9-81ED-4DB2-BD59-A6C34878D82A}">
+                    <a16:rowId xmlns:a16="http://schemas.microsoft.com/office/drawing/2014/main" val="10002"/>
+                  </a:ext>
+                </a:extLst>
               </a:tr>
               <a:tr h="655320">
                 <a:tc>
@@ -6732,6 +6818,11 @@
                     </a:solidFill>
                   </a:tcPr>
                 </a:tc>
+                <a:extLst>
+                  <a:ext uri="{0D108BD9-81ED-4DB2-BD59-A6C34878D82A}">
+                    <a16:rowId xmlns:a16="http://schemas.microsoft.com/office/drawing/2014/main" val="10003"/>
+                  </a:ext>
+                </a:extLst>
               </a:tr>
               <a:tr h="655320">
                 <a:tc>
@@ -6780,6 +6871,11 @@
                     </a:solidFill>
                   </a:tcPr>
                 </a:tc>
+                <a:extLst>
+                  <a:ext uri="{0D108BD9-81ED-4DB2-BD59-A6C34878D82A}">
+                    <a16:rowId xmlns:a16="http://schemas.microsoft.com/office/drawing/2014/main" val="10004"/>
+                  </a:ext>
+                </a:extLst>
               </a:tr>
               <a:tr h="655320">
                 <a:tc>
@@ -6828,6 +6924,11 @@
                     </a:solidFill>
                   </a:tcPr>
                 </a:tc>
+                <a:extLst>
+                  <a:ext uri="{0D108BD9-81ED-4DB2-BD59-A6C34878D82A}">
+                    <a16:rowId xmlns:a16="http://schemas.microsoft.com/office/drawing/2014/main" val="10005"/>
+                  </a:ext>
+                </a:extLst>
               </a:tr>
             </a:tbl>
           </a:graphicData>
@@ -6850,7 +6951,7 @@
           <a:noFill/>
         </p:spPr>
         <p:txBody>
-          <a:bodyPr wrap="square" anchor="t" lIns="27432" rIns="27432" tIns="18288" bIns="18288">
+          <a:bodyPr wrap="square" lIns="27432" tIns="18288" rIns="27432" bIns="18288" anchor="t">
             <a:spAutoFit/>
           </a:bodyPr>
           <a:lstStyle/>
@@ -6910,7 +7011,7 @@
           </a:fontRef>
         </p:style>
         <p:txBody>
-          <a:bodyPr rtlCol="0" anchor="ctr" wrap="square"/>
+          <a:bodyPr wrap="square" rtlCol="0" anchor="ctr"/>
           <a:lstStyle/>
           <a:p>
             <a:pPr algn="ctr" latinLnBrk="0"/>
@@ -6935,7 +7036,7 @@
 </file>
 
 <file path=ppt/slides/slide7.xml><?xml version="1.0" encoding="utf-8"?>
-<p:sld xmlns:a="http://schemas.openxmlformats.org/drawingml/2006/main" xmlns:p="http://schemas.openxmlformats.org/presentationml/2006/main" xmlns:r="http://schemas.openxmlformats.org/officeDocument/2006/relationships">
+<p:sld xmlns:a="http://schemas.openxmlformats.org/drawingml/2006/main" xmlns:r="http://schemas.openxmlformats.org/officeDocument/2006/relationships" xmlns:p="http://schemas.openxmlformats.org/presentationml/2006/main">
   <p:cSld>
     <p:bg>
       <p:bgPr>
@@ -6951,7 +7052,14 @@
         <p:cNvGrpSpPr/>
         <p:nvPr/>
       </p:nvGrpSpPr>
-      <p:grpSpPr/>
+      <p:grpSpPr>
+        <a:xfrm>
+          <a:off x="0" y="0"/>
+          <a:ext cx="0" cy="0"/>
+          <a:chOff x="0" y="0"/>
+          <a:chExt cx="0" cy="0"/>
+        </a:xfrm>
+      </p:grpSpPr>
       <p:sp>
         <p:nvSpPr>
           <p:cNvPr id="2" name="TextBox 1"/>
@@ -6969,7 +7077,7 @@
           <a:noFill/>
         </p:spPr>
         <p:txBody>
-          <a:bodyPr wrap="square" anchor="t" lIns="27432" rIns="27432" tIns="18288" bIns="18288">
+          <a:bodyPr wrap="square" lIns="27432" tIns="18288" rIns="27432" bIns="18288" anchor="t">
             <a:spAutoFit/>
           </a:bodyPr>
           <a:lstStyle/>
@@ -7008,7 +7116,7 @@
           <a:noFill/>
         </p:spPr>
         <p:txBody>
-          <a:bodyPr wrap="square" anchor="t" lIns="27432" rIns="27432" tIns="18288" bIns="18288">
+          <a:bodyPr wrap="square" lIns="27432" tIns="18288" rIns="27432" bIns="18288" anchor="t">
             <a:spAutoFit/>
           </a:bodyPr>
           <a:lstStyle/>
@@ -7047,7 +7155,7 @@
           <a:noFill/>
         </p:spPr>
         <p:txBody>
-          <a:bodyPr wrap="square" anchor="t" lIns="27432" rIns="27432" tIns="18288" bIns="18288">
+          <a:bodyPr wrap="square" lIns="27432" tIns="18288" rIns="27432" bIns="18288" anchor="t">
             <a:spAutoFit/>
           </a:bodyPr>
           <a:lstStyle/>
@@ -7077,7 +7185,7 @@
         </p:nvSpPr>
         <p:spPr>
           <a:xfrm>
-            <a:off x="502920" y="6510528"/>
+            <a:off x="502920" y="6629400"/>
             <a:ext cx="4572000" cy="274320"/>
           </a:xfrm>
           <a:prstGeom prst="rect">
@@ -7086,7 +7194,7 @@
           <a:noFill/>
         </p:spPr>
         <p:txBody>
-          <a:bodyPr wrap="square" anchor="t" lIns="27432" rIns="27432" tIns="18288" bIns="18288">
+          <a:bodyPr wrap="square" lIns="27432" tIns="18288" rIns="27432" bIns="18288" anchor="t">
             <a:spAutoFit/>
           </a:bodyPr>
           <a:lstStyle/>
@@ -7097,7 +7205,7 @@
               </a:lnSpc>
             </a:pPr>
             <a:r>
-              <a:rPr sz="1000" b="0">
+              <a:rPr sz="1000" b="0" dirty="0">
                 <a:solidFill>
                   <a:srgbClr val="6E6A60"/>
                 </a:solidFill>
@@ -7148,7 +7256,7 @@
           </a:fontRef>
         </p:style>
         <p:txBody>
-          <a:bodyPr rtlCol="0" anchor="t" wrap="square" lIns="201168" rIns="201168" tIns="146304"/>
+          <a:bodyPr wrap="square" lIns="201168" tIns="146304" rIns="201168" rtlCol="0" anchor="t"/>
           <a:lstStyle/>
           <a:p>
             <a:pPr algn="l" latinLnBrk="0">
@@ -7188,15 +7296,12 @@
                 <a:spcPts val="400"/>
               </a:spcAft>
             </a:pPr>
-            <a:r>
-              <a:rPr sz="1350" b="0">
-                <a:solidFill>
-                  <a:srgbClr val="24262E"/>
-                </a:solidFill>
-                <a:latin typeface="Segoe UI"/>
-              </a:rPr>
-              <a:t/>
-            </a:r>
+            <a:endParaRPr sz="1350" b="0">
+              <a:solidFill>
+                <a:srgbClr val="24262E"/>
+              </a:solidFill>
+              <a:latin typeface="Segoe UI"/>
+            </a:endParaRPr>
           </a:p>
           <a:p>
             <a:pPr algn="l" latinLnBrk="0">
@@ -7256,7 +7361,7 @@
           </a:fontRef>
         </p:style>
         <p:txBody>
-          <a:bodyPr rtlCol="0" anchor="t" wrap="square" lIns="201168" rIns="201168" tIns="146304"/>
+          <a:bodyPr wrap="square" lIns="201168" tIns="146304" rIns="201168" rtlCol="0" anchor="t"/>
           <a:lstStyle/>
           <a:p>
             <a:pPr algn="l" latinLnBrk="0">
@@ -7296,15 +7401,12 @@
                 <a:spcPts val="400"/>
               </a:spcAft>
             </a:pPr>
-            <a:r>
-              <a:rPr sz="1350" b="0">
-                <a:solidFill>
-                  <a:srgbClr val="24262E"/>
-                </a:solidFill>
-                <a:latin typeface="Segoe UI"/>
-              </a:rPr>
-              <a:t/>
-            </a:r>
+            <a:endParaRPr sz="1350" b="0">
+              <a:solidFill>
+                <a:srgbClr val="24262E"/>
+              </a:solidFill>
+              <a:latin typeface="Segoe UI"/>
+            </a:endParaRPr>
           </a:p>
           <a:p>
             <a:pPr algn="l" latinLnBrk="0">
@@ -7364,7 +7466,7 @@
           </a:fontRef>
         </p:style>
         <p:txBody>
-          <a:bodyPr rtlCol="0" anchor="t" wrap="square" lIns="201168" rIns="201168" tIns="146304"/>
+          <a:bodyPr wrap="square" lIns="201168" tIns="146304" rIns="201168" rtlCol="0" anchor="t"/>
           <a:lstStyle/>
           <a:p>
             <a:pPr algn="l" latinLnBrk="0">
@@ -7404,15 +7506,12 @@
                 <a:spcPts val="400"/>
               </a:spcAft>
             </a:pPr>
-            <a:r>
-              <a:rPr sz="1350" b="0">
-                <a:solidFill>
-                  <a:srgbClr val="24262E"/>
-                </a:solidFill>
-                <a:latin typeface="Segoe UI"/>
-              </a:rPr>
-              <a:t/>
-            </a:r>
+            <a:endParaRPr sz="1350" b="0">
+              <a:solidFill>
+                <a:srgbClr val="24262E"/>
+              </a:solidFill>
+              <a:latin typeface="Segoe UI"/>
+            </a:endParaRPr>
           </a:p>
           <a:p>
             <a:pPr algn="l" latinLnBrk="0">
@@ -7436,15 +7535,12 @@
                 <a:spcPts val="400"/>
               </a:spcAft>
             </a:pPr>
-            <a:r>
-              <a:rPr sz="1350" b="0">
-                <a:solidFill>
-                  <a:srgbClr val="24262E"/>
-                </a:solidFill>
-                <a:latin typeface="Segoe UI"/>
-              </a:rPr>
-              <a:t/>
-            </a:r>
+            <a:endParaRPr sz="1350" b="0">
+              <a:solidFill>
+                <a:srgbClr val="24262E"/>
+              </a:solidFill>
+              <a:latin typeface="Segoe UI"/>
+            </a:endParaRPr>
           </a:p>
           <a:p>
             <a:pPr algn="l" latinLnBrk="0">
@@ -7502,7 +7598,7 @@
           </a:fontRef>
         </p:style>
         <p:txBody>
-          <a:bodyPr rtlCol="0" anchor="ctr" wrap="square"/>
+          <a:bodyPr wrap="square" rtlCol="0" anchor="ctr"/>
           <a:lstStyle/>
           <a:p>
             <a:pPr algn="ctr" latinLnBrk="0"/>
@@ -7527,7 +7623,7 @@
 </file>
 
 <file path=ppt/slides/slide8.xml><?xml version="1.0" encoding="utf-8"?>
-<p:sld xmlns:a="http://schemas.openxmlformats.org/drawingml/2006/main" xmlns:p="http://schemas.openxmlformats.org/presentationml/2006/main" xmlns:r="http://schemas.openxmlformats.org/officeDocument/2006/relationships">
+<p:sld xmlns:a="http://schemas.openxmlformats.org/drawingml/2006/main" xmlns:r="http://schemas.openxmlformats.org/officeDocument/2006/relationships" xmlns:p="http://schemas.openxmlformats.org/presentationml/2006/main">
   <p:cSld>
     <p:bg>
       <p:bgPr>
@@ -7543,7 +7639,14 @@
         <p:cNvGrpSpPr/>
         <p:nvPr/>
       </p:nvGrpSpPr>
-      <p:grpSpPr/>
+      <p:grpSpPr>
+        <a:xfrm>
+          <a:off x="0" y="0"/>
+          <a:ext cx="0" cy="0"/>
+          <a:chOff x="0" y="0"/>
+          <a:chExt cx="0" cy="0"/>
+        </a:xfrm>
+      </p:grpSpPr>
       <p:sp>
         <p:nvSpPr>
           <p:cNvPr id="2" name="TextBox 1"/>
@@ -7561,7 +7664,7 @@
           <a:noFill/>
         </p:spPr>
         <p:txBody>
-          <a:bodyPr wrap="square" anchor="t" lIns="27432" rIns="27432" tIns="18288" bIns="18288">
+          <a:bodyPr wrap="square" lIns="27432" tIns="18288" rIns="27432" bIns="18288" anchor="t">
             <a:spAutoFit/>
           </a:bodyPr>
           <a:lstStyle/>
@@ -7600,7 +7703,7 @@
           <a:noFill/>
         </p:spPr>
         <p:txBody>
-          <a:bodyPr wrap="square" anchor="t" lIns="27432" rIns="27432" tIns="18288" bIns="18288">
+          <a:bodyPr wrap="square" lIns="27432" tIns="18288" rIns="27432" bIns="18288" anchor="t">
             <a:spAutoFit/>
           </a:bodyPr>
           <a:lstStyle/>
@@ -7639,7 +7742,7 @@
           <a:noFill/>
         </p:spPr>
         <p:txBody>
-          <a:bodyPr wrap="square" anchor="t" lIns="27432" rIns="27432" tIns="18288" bIns="18288">
+          <a:bodyPr wrap="square" lIns="27432" tIns="18288" rIns="27432" bIns="18288" anchor="t">
             <a:spAutoFit/>
           </a:bodyPr>
           <a:lstStyle/>
@@ -7678,7 +7781,7 @@
           <a:noFill/>
         </p:spPr>
         <p:txBody>
-          <a:bodyPr wrap="square" anchor="t" lIns="27432" rIns="27432" tIns="18288" bIns="18288">
+          <a:bodyPr wrap="square" lIns="27432" tIns="18288" rIns="27432" bIns="18288" anchor="t">
             <a:spAutoFit/>
           </a:bodyPr>
           <a:lstStyle/>
@@ -7689,7 +7792,7 @@
               </a:lnSpc>
             </a:pPr>
             <a:r>
-              <a:rPr sz="1000" b="0">
+              <a:rPr sz="1000" b="0" dirty="0">
                 <a:solidFill>
                   <a:srgbClr val="6E6A60"/>
                 </a:solidFill>
@@ -7740,7 +7843,7 @@
           </a:fontRef>
         </p:style>
         <p:txBody>
-          <a:bodyPr rtlCol="0" anchor="t" wrap="square" lIns="201168" rIns="201168" tIns="146304"/>
+          <a:bodyPr wrap="square" lIns="201168" tIns="146304" rIns="201168" rtlCol="0" anchor="t"/>
           <a:lstStyle/>
           <a:p>
             <a:pPr algn="l" latinLnBrk="0">
@@ -7816,7 +7919,7 @@
           </a:fontRef>
         </p:style>
         <p:txBody>
-          <a:bodyPr rtlCol="0" anchor="t" wrap="square" lIns="201168" rIns="201168" tIns="146304"/>
+          <a:bodyPr wrap="square" lIns="201168" tIns="146304" rIns="201168" rtlCol="0" anchor="t"/>
           <a:lstStyle/>
           <a:p>
             <a:pPr algn="l" latinLnBrk="0">
@@ -7869,7 +7972,7 @@
           <a:noFill/>
         </p:spPr>
         <p:txBody>
-          <a:bodyPr wrap="square" anchor="t" lIns="27432" rIns="27432" tIns="18288" bIns="18288">
+          <a:bodyPr wrap="square" lIns="27432" tIns="18288" rIns="27432" bIns="18288" anchor="t">
             <a:spAutoFit/>
           </a:bodyPr>
           <a:lstStyle/>

</xml_diff>